<commit_message>
Product Variant item- Working with edit feature
</commit_message>
<xml_diff>
--- a/.lessons/58 Backend Product And Related Features/28 Product Variant item- Working with edit feature/1.pptx
+++ b/.lessons/58 Backend Product And Related Features/28 Product Variant item- Working with edit feature/1.pptx
@@ -8,6 +8,10 @@
     <p:sldId id="413" r:id="rId2"/>
     <p:sldId id="414" r:id="rId3"/>
     <p:sldId id="400" r:id="rId4"/>
+    <p:sldId id="415" r:id="rId5"/>
+    <p:sldId id="416" r:id="rId6"/>
+    <p:sldId id="417" r:id="rId7"/>
+    <p:sldId id="418" r:id="rId8"/>
   </p:sldIdLst>
   <p:sldSz cx="12192000" cy="6858000"/>
   <p:notesSz cx="6858000" cy="9144000"/>
@@ -261,7 +265,7 @@
           <a:p>
             <a:fld id="{3E102D2E-813C-461C-9963-687A650C48C0}" type="datetimeFigureOut">
               <a:rPr lang="en-US" smtClean="0"/>
-              <a:t>6/26/2025</a:t>
+              <a:t>10/9/2025</a:t>
             </a:fld>
             <a:endParaRPr lang="en-US"/>
           </a:p>
@@ -459,7 +463,7 @@
           <a:p>
             <a:fld id="{3E102D2E-813C-461C-9963-687A650C48C0}" type="datetimeFigureOut">
               <a:rPr lang="en-US" smtClean="0"/>
-              <a:t>6/26/2025</a:t>
+              <a:t>10/9/2025</a:t>
             </a:fld>
             <a:endParaRPr lang="en-US"/>
           </a:p>
@@ -667,7 +671,7 @@
           <a:p>
             <a:fld id="{3E102D2E-813C-461C-9963-687A650C48C0}" type="datetimeFigureOut">
               <a:rPr lang="en-US" smtClean="0"/>
-              <a:t>6/26/2025</a:t>
+              <a:t>10/9/2025</a:t>
             </a:fld>
             <a:endParaRPr lang="en-US"/>
           </a:p>
@@ -865,7 +869,7 @@
           <a:p>
             <a:fld id="{3E102D2E-813C-461C-9963-687A650C48C0}" type="datetimeFigureOut">
               <a:rPr lang="en-US" smtClean="0"/>
-              <a:t>6/26/2025</a:t>
+              <a:t>10/9/2025</a:t>
             </a:fld>
             <a:endParaRPr lang="en-US"/>
           </a:p>
@@ -1140,7 +1144,7 @@
           <a:p>
             <a:fld id="{3E102D2E-813C-461C-9963-687A650C48C0}" type="datetimeFigureOut">
               <a:rPr lang="en-US" smtClean="0"/>
-              <a:t>6/26/2025</a:t>
+              <a:t>10/9/2025</a:t>
             </a:fld>
             <a:endParaRPr lang="en-US"/>
           </a:p>
@@ -1405,7 +1409,7 @@
           <a:p>
             <a:fld id="{3E102D2E-813C-461C-9963-687A650C48C0}" type="datetimeFigureOut">
               <a:rPr lang="en-US" smtClean="0"/>
-              <a:t>6/26/2025</a:t>
+              <a:t>10/9/2025</a:t>
             </a:fld>
             <a:endParaRPr lang="en-US"/>
           </a:p>
@@ -1817,7 +1821,7 @@
           <a:p>
             <a:fld id="{3E102D2E-813C-461C-9963-687A650C48C0}" type="datetimeFigureOut">
               <a:rPr lang="en-US" smtClean="0"/>
-              <a:t>6/26/2025</a:t>
+              <a:t>10/9/2025</a:t>
             </a:fld>
             <a:endParaRPr lang="en-US"/>
           </a:p>
@@ -1958,7 +1962,7 @@
           <a:p>
             <a:fld id="{3E102D2E-813C-461C-9963-687A650C48C0}" type="datetimeFigureOut">
               <a:rPr lang="en-US" smtClean="0"/>
-              <a:t>6/26/2025</a:t>
+              <a:t>10/9/2025</a:t>
             </a:fld>
             <a:endParaRPr lang="en-US"/>
           </a:p>
@@ -2071,7 +2075,7 @@
           <a:p>
             <a:fld id="{3E102D2E-813C-461C-9963-687A650C48C0}" type="datetimeFigureOut">
               <a:rPr lang="en-US" smtClean="0"/>
-              <a:t>6/26/2025</a:t>
+              <a:t>10/9/2025</a:t>
             </a:fld>
             <a:endParaRPr lang="en-US"/>
           </a:p>
@@ -2382,7 +2386,7 @@
           <a:p>
             <a:fld id="{3E102D2E-813C-461C-9963-687A650C48C0}" type="datetimeFigureOut">
               <a:rPr lang="en-US" smtClean="0"/>
-              <a:t>6/26/2025</a:t>
+              <a:t>10/9/2025</a:t>
             </a:fld>
             <a:endParaRPr lang="en-US"/>
           </a:p>
@@ -2670,7 +2674,7 @@
           <a:p>
             <a:fld id="{3E102D2E-813C-461C-9963-687A650C48C0}" type="datetimeFigureOut">
               <a:rPr lang="en-US" smtClean="0"/>
-              <a:t>6/26/2025</a:t>
+              <a:t>10/9/2025</a:t>
             </a:fld>
             <a:endParaRPr lang="en-US"/>
           </a:p>
@@ -2911,7 +2915,7 @@
           <a:p>
             <a:fld id="{3E102D2E-813C-461C-9963-687A650C48C0}" type="datetimeFigureOut">
               <a:rPr lang="en-US" smtClean="0"/>
-              <a:t>6/26/2025</a:t>
+              <a:t>10/9/2025</a:t>
             </a:fld>
             <a:endParaRPr lang="en-US"/>
           </a:p>
@@ -3348,8 +3352,8 @@
         </p:nvSpPr>
         <p:spPr>
           <a:xfrm>
-            <a:off x="217714" y="255046"/>
-            <a:ext cx="11756571" cy="355354"/>
+            <a:off x="83128" y="98028"/>
+            <a:ext cx="11756571" cy="335156"/>
           </a:xfrm>
           <a:prstGeom prst="rect">
             <a:avLst/>
@@ -3369,21 +3373,54 @@
               <a:buNone/>
             </a:pPr>
             <a:r>
-              <a:rPr kumimoji="0" lang="en-US" altLang="en-US" sz="1300" b="0" i="0" u="none" strike="noStrike" cap="none" normalizeH="0" baseline="0">
-                <a:ln>
-                  <a:noFill/>
-                </a:ln>
-                <a:solidFill>
-                  <a:schemeClr val="tx1"/>
-                </a:solidFill>
-                <a:effectLst/>
+              <a:rPr lang="en-US" altLang="en-US" sz="1200">
                 <a:latin typeface="Arial" panose="020B0604020202020204" pitchFamily="34" charset="0"/>
               </a:rPr>
-              <a:t>.</a:t>
-            </a:r>
-          </a:p>
-        </p:txBody>
-      </p:sp>
+              <a:t>app\Http\Controllers\Backend\ProductVariantItemController.php</a:t>
+            </a:r>
+            <a:endParaRPr kumimoji="0" lang="en-US" altLang="en-US" sz="1200" b="0" i="0" u="none" strike="noStrike" cap="none" normalizeH="0" baseline="0">
+              <a:ln>
+                <a:noFill/>
+              </a:ln>
+              <a:solidFill>
+                <a:schemeClr val="tx1"/>
+              </a:solidFill>
+              <a:effectLst/>
+              <a:latin typeface="Arial" panose="020B0604020202020204" pitchFamily="34" charset="0"/>
+            </a:endParaRPr>
+          </a:p>
+        </p:txBody>
+      </p:sp>
+      <p:pic>
+        <p:nvPicPr>
+          <p:cNvPr id="6" name="Picture 5">
+            <a:extLst>
+              <a:ext uri="{FF2B5EF4-FFF2-40B4-BE49-F238E27FC236}">
+                <a16:creationId xmlns:a16="http://schemas.microsoft.com/office/drawing/2014/main" id="{232488AE-EEEC-CAED-6779-3A71DA9AB6AB}"/>
+              </a:ext>
+            </a:extLst>
+          </p:cNvPr>
+          <p:cNvPicPr>
+            <a:picLocks noChangeAspect="1"/>
+          </p:cNvPicPr>
+          <p:nvPr/>
+        </p:nvPicPr>
+        <p:blipFill>
+          <a:blip r:embed="rId2"/>
+          <a:stretch>
+            <a:fillRect/>
+          </a:stretch>
+        </p:blipFill>
+        <p:spPr>
+          <a:xfrm>
+            <a:off x="4702222" y="0"/>
+            <a:ext cx="7489778" cy="6858000"/>
+          </a:xfrm>
+          <a:prstGeom prst="rect">
+            <a:avLst/>
+          </a:prstGeom>
+        </p:spPr>
+      </p:pic>
     </p:spTree>
     <p:extLst>
       <p:ext uri="{BB962C8B-B14F-4D97-AF65-F5344CB8AC3E}">
@@ -3434,8 +3471,8 @@
         </p:nvSpPr>
         <p:spPr>
           <a:xfrm>
-            <a:off x="217714" y="255046"/>
-            <a:ext cx="11756571" cy="355354"/>
+            <a:off x="0" y="181155"/>
+            <a:ext cx="11756571" cy="335156"/>
           </a:xfrm>
           <a:prstGeom prst="rect">
             <a:avLst/>
@@ -3455,21 +3492,54 @@
               <a:buNone/>
             </a:pPr>
             <a:r>
-              <a:rPr kumimoji="0" lang="en-US" altLang="en-US" sz="1300" b="0" i="0" u="none" strike="noStrike" cap="none" normalizeH="0" baseline="0">
-                <a:ln>
-                  <a:noFill/>
-                </a:ln>
-                <a:solidFill>
-                  <a:schemeClr val="tx1"/>
-                </a:solidFill>
-                <a:effectLst/>
+              <a:rPr lang="en-US" altLang="en-US" sz="1200">
                 <a:latin typeface="Arial" panose="020B0604020202020204" pitchFamily="34" charset="0"/>
               </a:rPr>
-              <a:t>.</a:t>
-            </a:r>
-          </a:p>
-        </p:txBody>
-      </p:sp>
+              <a:t>resources\views\admin\product\product-variant-item\edit.blade.php</a:t>
+            </a:r>
+            <a:endParaRPr kumimoji="0" lang="en-US" altLang="en-US" sz="1200" b="0" i="0" u="none" strike="noStrike" cap="none" normalizeH="0" baseline="0">
+              <a:ln>
+                <a:noFill/>
+              </a:ln>
+              <a:solidFill>
+                <a:schemeClr val="tx1"/>
+              </a:solidFill>
+              <a:effectLst/>
+              <a:latin typeface="Arial" panose="020B0604020202020204" pitchFamily="34" charset="0"/>
+            </a:endParaRPr>
+          </a:p>
+        </p:txBody>
+      </p:sp>
+      <p:pic>
+        <p:nvPicPr>
+          <p:cNvPr id="4" name="Picture 3">
+            <a:extLst>
+              <a:ext uri="{FF2B5EF4-FFF2-40B4-BE49-F238E27FC236}">
+                <a16:creationId xmlns:a16="http://schemas.microsoft.com/office/drawing/2014/main" id="{BC63899D-627F-0885-79CC-8D10DD01DF19}"/>
+              </a:ext>
+            </a:extLst>
+          </p:cNvPr>
+          <p:cNvPicPr>
+            <a:picLocks noChangeAspect="1"/>
+          </p:cNvPicPr>
+          <p:nvPr/>
+        </p:nvPicPr>
+        <p:blipFill>
+          <a:blip r:embed="rId2"/>
+          <a:stretch>
+            <a:fillRect/>
+          </a:stretch>
+        </p:blipFill>
+        <p:spPr>
+          <a:xfrm>
+            <a:off x="5243304" y="0"/>
+            <a:ext cx="6948696" cy="6858000"/>
+          </a:xfrm>
+          <a:prstGeom prst="rect">
+            <a:avLst/>
+          </a:prstGeom>
+        </p:spPr>
+      </p:pic>
     </p:spTree>
     <p:extLst>
       <p:ext uri="{BB962C8B-B14F-4D97-AF65-F5344CB8AC3E}">
@@ -3520,6 +3590,220 @@
         </p:nvSpPr>
         <p:spPr>
           <a:xfrm>
+            <a:off x="217714" y="144210"/>
+            <a:ext cx="11756571" cy="955518"/>
+          </a:xfrm>
+          <a:prstGeom prst="rect">
+            <a:avLst/>
+          </a:prstGeom>
+          <a:noFill/>
+        </p:spPr>
+        <p:txBody>
+          <a:bodyPr wrap="square">
+            <a:spAutoFit/>
+          </a:bodyPr>
+          <a:lstStyle/>
+          <a:p>
+            <a:pPr>
+              <a:lnSpc>
+                <a:spcPct val="150000"/>
+              </a:lnSpc>
+              <a:buNone/>
+            </a:pPr>
+            <a:r>
+              <a:rPr lang="en-US" altLang="en-US" sz="1300">
+                <a:latin typeface="Arial" panose="020B0604020202020204" pitchFamily="34" charset="0"/>
+              </a:rPr>
+              <a:t>app\Http\Controllers\Backend\ProductVariantItemController.php</a:t>
+            </a:r>
+            <a:endParaRPr lang="az-Latn-AZ" altLang="en-US" sz="1300">
+              <a:latin typeface="Arial" panose="020B0604020202020204" pitchFamily="34" charset="0"/>
+            </a:endParaRPr>
+          </a:p>
+          <a:p>
+            <a:pPr>
+              <a:lnSpc>
+                <a:spcPct val="150000"/>
+              </a:lnSpc>
+              <a:buNone/>
+            </a:pPr>
+            <a:endParaRPr kumimoji="0" lang="az-Latn-AZ" altLang="en-US" sz="1300" b="0" i="0" u="none" strike="noStrike" cap="none" normalizeH="0" baseline="0">
+              <a:ln>
+                <a:noFill/>
+              </a:ln>
+              <a:solidFill>
+                <a:schemeClr val="tx1"/>
+              </a:solidFill>
+              <a:effectLst/>
+              <a:latin typeface="Arial" panose="020B0604020202020204" pitchFamily="34" charset="0"/>
+            </a:endParaRPr>
+          </a:p>
+          <a:p>
+            <a:pPr>
+              <a:lnSpc>
+                <a:spcPct val="150000"/>
+              </a:lnSpc>
+              <a:buNone/>
+            </a:pPr>
+            <a:r>
+              <a:rPr lang="az-Latn-AZ" altLang="en-US" sz="1300">
+                <a:latin typeface="Arial" panose="020B0604020202020204" pitchFamily="34" charset="0"/>
+              </a:rPr>
+              <a:t>Diqqət edin ki, </a:t>
+            </a:r>
+            <a:r>
+              <a:rPr lang="az-Latn-AZ" altLang="en-US" sz="1300" b="1">
+                <a:latin typeface="Arial" panose="020B0604020202020204" pitchFamily="34" charset="0"/>
+              </a:rPr>
+              <a:t>product</a:t>
+            </a:r>
+            <a:r>
+              <a:rPr lang="en-US" altLang="en-US" sz="1300">
+                <a:latin typeface="Arial" panose="020B0604020202020204" pitchFamily="34" charset="0"/>
+              </a:rPr>
+              <a:t>id </a:t>
+            </a:r>
+            <a:r>
+              <a:rPr lang="az-Latn-AZ" altLang="en-US" sz="1300">
+                <a:latin typeface="Arial" panose="020B0604020202020204" pitchFamily="34" charset="0"/>
+              </a:rPr>
+              <a:t>və </a:t>
+            </a:r>
+            <a:r>
+              <a:rPr lang="en-US" altLang="en-US" sz="1300" b="1">
+                <a:latin typeface="Arial" panose="020B0604020202020204" pitchFamily="34" charset="0"/>
+              </a:rPr>
+              <a:t>VariantId</a:t>
+            </a:r>
+            <a:r>
+              <a:rPr lang="en-US" altLang="en-US" sz="1300">
+                <a:latin typeface="Arial" panose="020B0604020202020204" pitchFamily="34" charset="0"/>
+              </a:rPr>
+              <a:t> </a:t>
+            </a:r>
+            <a:r>
+              <a:rPr lang="az-Latn-AZ" altLang="en-US" sz="1300">
+                <a:latin typeface="Arial" panose="020B0604020202020204" pitchFamily="34" charset="0"/>
+              </a:rPr>
+              <a:t>adları </a:t>
+            </a:r>
+            <a:r>
+              <a:rPr lang="en-US" altLang="en-US" sz="1300" b="1">
+                <a:latin typeface="Arial" panose="020B0604020202020204" pitchFamily="34" charset="0"/>
+              </a:rPr>
+              <a:t>web.php </a:t>
+            </a:r>
+            <a:r>
+              <a:rPr lang="az-Latn-AZ" altLang="en-US" sz="1300">
+                <a:latin typeface="Arial" panose="020B0604020202020204" pitchFamily="34" charset="0"/>
+              </a:rPr>
+              <a:t>faylındakı routda yazılan </a:t>
+            </a:r>
+            <a:r>
+              <a:rPr lang="en-US" altLang="en-US" sz="1300" b="1">
+                <a:latin typeface="Arial" panose="020B0604020202020204" pitchFamily="34" charset="0"/>
+              </a:rPr>
+              <a:t>/productid/variantId </a:t>
+            </a:r>
+            <a:r>
+              <a:rPr lang="az-Latn-AZ" altLang="en-US" sz="1300">
+                <a:latin typeface="Arial" panose="020B0604020202020204" pitchFamily="34" charset="0"/>
+              </a:rPr>
+              <a:t>ilə eyni olsun.</a:t>
+            </a:r>
+            <a:endParaRPr kumimoji="0" lang="en-US" altLang="en-US" sz="1300" b="0" i="0" u="none" strike="noStrike" cap="none" normalizeH="0" baseline="0">
+              <a:ln>
+                <a:noFill/>
+              </a:ln>
+              <a:solidFill>
+                <a:schemeClr val="tx1"/>
+              </a:solidFill>
+              <a:effectLst/>
+              <a:latin typeface="Arial" panose="020B0604020202020204" pitchFamily="34" charset="0"/>
+            </a:endParaRPr>
+          </a:p>
+        </p:txBody>
+      </p:sp>
+      <p:pic>
+        <p:nvPicPr>
+          <p:cNvPr id="4" name="Picture 3">
+            <a:extLst>
+              <a:ext uri="{FF2B5EF4-FFF2-40B4-BE49-F238E27FC236}">
+                <a16:creationId xmlns:a16="http://schemas.microsoft.com/office/drawing/2014/main" id="{48B5566D-4F25-D270-380A-43A9099222AC}"/>
+              </a:ext>
+            </a:extLst>
+          </p:cNvPr>
+          <p:cNvPicPr>
+            <a:picLocks noChangeAspect="1"/>
+          </p:cNvPicPr>
+          <p:nvPr/>
+        </p:nvPicPr>
+        <p:blipFill>
+          <a:blip r:embed="rId2"/>
+          <a:stretch>
+            <a:fillRect/>
+          </a:stretch>
+        </p:blipFill>
+        <p:spPr>
+          <a:xfrm>
+            <a:off x="1856509" y="1397896"/>
+            <a:ext cx="10335491" cy="5460104"/>
+          </a:xfrm>
+          <a:prstGeom prst="rect">
+            <a:avLst/>
+          </a:prstGeom>
+        </p:spPr>
+      </p:pic>
+    </p:spTree>
+    <p:extLst>
+      <p:ext uri="{BB962C8B-B14F-4D97-AF65-F5344CB8AC3E}">
+        <p14:creationId xmlns:p14="http://schemas.microsoft.com/office/powerpoint/2010/main" val="3095838342"/>
+      </p:ext>
+    </p:extLst>
+  </p:cSld>
+  <p:clrMapOvr>
+    <a:masterClrMapping/>
+  </p:clrMapOvr>
+</p:sld>
+</file>
+
+<file path=ppt/slides/slide4.xml><?xml version="1.0" encoding="utf-8"?>
+<p:sld xmlns:a="http://schemas.openxmlformats.org/drawingml/2006/main" xmlns:r="http://schemas.openxmlformats.org/officeDocument/2006/relationships" xmlns:p="http://schemas.openxmlformats.org/presentationml/2006/main">
+  <p:cSld>
+    <p:spTree>
+      <p:nvGrpSpPr>
+        <p:cNvPr id="1" name="">
+          <a:extLst>
+            <a:ext uri="{FF2B5EF4-FFF2-40B4-BE49-F238E27FC236}">
+              <a16:creationId xmlns:a16="http://schemas.microsoft.com/office/drawing/2014/main" id="{BDE183C5-45AD-6BE8-4E50-CFAF61C9B4D4}"/>
+            </a:ext>
+          </a:extLst>
+        </p:cNvPr>
+        <p:cNvGrpSpPr/>
+        <p:nvPr/>
+      </p:nvGrpSpPr>
+      <p:grpSpPr>
+        <a:xfrm>
+          <a:off x="0" y="0"/>
+          <a:ext cx="0" cy="0"/>
+          <a:chOff x="0" y="0"/>
+          <a:chExt cx="0" cy="0"/>
+        </a:xfrm>
+      </p:grpSpPr>
+      <p:sp>
+        <p:nvSpPr>
+          <p:cNvPr id="3" name="TextBox 2">
+            <a:extLst>
+              <a:ext uri="{FF2B5EF4-FFF2-40B4-BE49-F238E27FC236}">
+                <a16:creationId xmlns:a16="http://schemas.microsoft.com/office/drawing/2014/main" id="{DB403D79-6F64-5A32-B768-93576953710A}"/>
+              </a:ext>
+            </a:extLst>
+          </p:cNvPr>
+          <p:cNvSpPr txBox="1"/>
+          <p:nvPr/>
+        </p:nvSpPr>
+        <p:spPr>
+          <a:xfrm>
             <a:off x="217714" y="255046"/>
             <a:ext cx="11756571" cy="355354"/>
           </a:xfrm>
@@ -3556,10 +3840,308 @@
           </a:p>
         </p:txBody>
       </p:sp>
+      <p:pic>
+        <p:nvPicPr>
+          <p:cNvPr id="4" name="Picture 3">
+            <a:extLst>
+              <a:ext uri="{FF2B5EF4-FFF2-40B4-BE49-F238E27FC236}">
+                <a16:creationId xmlns:a16="http://schemas.microsoft.com/office/drawing/2014/main" id="{E39DB042-A45E-2F58-D644-4AF0C77FF821}"/>
+              </a:ext>
+            </a:extLst>
+          </p:cNvPr>
+          <p:cNvPicPr>
+            <a:picLocks noChangeAspect="1"/>
+          </p:cNvPicPr>
+          <p:nvPr/>
+        </p:nvPicPr>
+        <p:blipFill>
+          <a:blip r:embed="rId2"/>
+          <a:stretch>
+            <a:fillRect/>
+          </a:stretch>
+        </p:blipFill>
+        <p:spPr>
+          <a:xfrm>
+            <a:off x="0" y="1831706"/>
+            <a:ext cx="12192000" cy="4358370"/>
+          </a:xfrm>
+          <a:prstGeom prst="rect">
+            <a:avLst/>
+          </a:prstGeom>
+          <a:ln>
+            <a:noFill/>
+          </a:ln>
+          <a:effectLst>
+            <a:outerShdw blurRad="292100" dist="139700" dir="2700000" algn="tl" rotWithShape="0">
+              <a:srgbClr val="333333">
+                <a:alpha val="65000"/>
+              </a:srgbClr>
+            </a:outerShdw>
+          </a:effectLst>
+        </p:spPr>
+      </p:pic>
     </p:spTree>
     <p:extLst>
       <p:ext uri="{BB962C8B-B14F-4D97-AF65-F5344CB8AC3E}">
-        <p14:creationId xmlns:p14="http://schemas.microsoft.com/office/powerpoint/2010/main" val="3095838342"/>
+        <p14:creationId xmlns:p14="http://schemas.microsoft.com/office/powerpoint/2010/main" val="2471013927"/>
+      </p:ext>
+    </p:extLst>
+  </p:cSld>
+  <p:clrMapOvr>
+    <a:masterClrMapping/>
+  </p:clrMapOvr>
+</p:sld>
+</file>
+
+<file path=ppt/slides/slide5.xml><?xml version="1.0" encoding="utf-8"?>
+<p:sld xmlns:a="http://schemas.openxmlformats.org/drawingml/2006/main" xmlns:r="http://schemas.openxmlformats.org/officeDocument/2006/relationships" xmlns:p="http://schemas.openxmlformats.org/presentationml/2006/main">
+  <p:cSld>
+    <p:spTree>
+      <p:nvGrpSpPr>
+        <p:cNvPr id="1" name="">
+          <a:extLst>
+            <a:ext uri="{FF2B5EF4-FFF2-40B4-BE49-F238E27FC236}">
+              <a16:creationId xmlns:a16="http://schemas.microsoft.com/office/drawing/2014/main" id="{A52E9F92-3D7D-A9DA-C286-D2B21CF90B48}"/>
+            </a:ext>
+          </a:extLst>
+        </p:cNvPr>
+        <p:cNvGrpSpPr/>
+        <p:nvPr/>
+      </p:nvGrpSpPr>
+      <p:grpSpPr>
+        <a:xfrm>
+          <a:off x="0" y="0"/>
+          <a:ext cx="0" cy="0"/>
+          <a:chOff x="0" y="0"/>
+          <a:chExt cx="0" cy="0"/>
+        </a:xfrm>
+      </p:grpSpPr>
+      <p:sp>
+        <p:nvSpPr>
+          <p:cNvPr id="3" name="TextBox 2">
+            <a:extLst>
+              <a:ext uri="{FF2B5EF4-FFF2-40B4-BE49-F238E27FC236}">
+                <a16:creationId xmlns:a16="http://schemas.microsoft.com/office/drawing/2014/main" id="{61659B76-7BF5-557D-E1BF-5265EB1F871B}"/>
+              </a:ext>
+            </a:extLst>
+          </p:cNvPr>
+          <p:cNvSpPr txBox="1"/>
+          <p:nvPr/>
+        </p:nvSpPr>
+        <p:spPr>
+          <a:xfrm>
+            <a:off x="217714" y="255046"/>
+            <a:ext cx="11756571" cy="355354"/>
+          </a:xfrm>
+          <a:prstGeom prst="rect">
+            <a:avLst/>
+          </a:prstGeom>
+          <a:noFill/>
+        </p:spPr>
+        <p:txBody>
+          <a:bodyPr wrap="square">
+            <a:spAutoFit/>
+          </a:bodyPr>
+          <a:lstStyle/>
+          <a:p>
+            <a:pPr>
+              <a:lnSpc>
+                <a:spcPct val="150000"/>
+              </a:lnSpc>
+              <a:buNone/>
+            </a:pPr>
+            <a:r>
+              <a:rPr kumimoji="0" lang="en-US" altLang="en-US" sz="1300" b="0" i="0" u="none" strike="noStrike" cap="none" normalizeH="0" baseline="0">
+                <a:ln>
+                  <a:noFill/>
+                </a:ln>
+                <a:solidFill>
+                  <a:schemeClr val="tx1"/>
+                </a:solidFill>
+                <a:effectLst/>
+                <a:latin typeface="Arial" panose="020B0604020202020204" pitchFamily="34" charset="0"/>
+              </a:rPr>
+              <a:t>.</a:t>
+            </a:r>
+          </a:p>
+        </p:txBody>
+      </p:sp>
+    </p:spTree>
+    <p:extLst>
+      <p:ext uri="{BB962C8B-B14F-4D97-AF65-F5344CB8AC3E}">
+        <p14:creationId xmlns:p14="http://schemas.microsoft.com/office/powerpoint/2010/main" val="3979724712"/>
+      </p:ext>
+    </p:extLst>
+  </p:cSld>
+  <p:clrMapOvr>
+    <a:masterClrMapping/>
+  </p:clrMapOvr>
+</p:sld>
+</file>
+
+<file path=ppt/slides/slide6.xml><?xml version="1.0" encoding="utf-8"?>
+<p:sld xmlns:a="http://schemas.openxmlformats.org/drawingml/2006/main" xmlns:r="http://schemas.openxmlformats.org/officeDocument/2006/relationships" xmlns:p="http://schemas.openxmlformats.org/presentationml/2006/main">
+  <p:cSld>
+    <p:spTree>
+      <p:nvGrpSpPr>
+        <p:cNvPr id="1" name="">
+          <a:extLst>
+            <a:ext uri="{FF2B5EF4-FFF2-40B4-BE49-F238E27FC236}">
+              <a16:creationId xmlns:a16="http://schemas.microsoft.com/office/drawing/2014/main" id="{C044A10F-65E8-6015-A9C0-FCD51145A984}"/>
+            </a:ext>
+          </a:extLst>
+        </p:cNvPr>
+        <p:cNvGrpSpPr/>
+        <p:nvPr/>
+      </p:nvGrpSpPr>
+      <p:grpSpPr>
+        <a:xfrm>
+          <a:off x="0" y="0"/>
+          <a:ext cx="0" cy="0"/>
+          <a:chOff x="0" y="0"/>
+          <a:chExt cx="0" cy="0"/>
+        </a:xfrm>
+      </p:grpSpPr>
+      <p:sp>
+        <p:nvSpPr>
+          <p:cNvPr id="3" name="TextBox 2">
+            <a:extLst>
+              <a:ext uri="{FF2B5EF4-FFF2-40B4-BE49-F238E27FC236}">
+                <a16:creationId xmlns:a16="http://schemas.microsoft.com/office/drawing/2014/main" id="{1823DB82-32B5-5CF6-EC7C-D95AF5F5C2AB}"/>
+              </a:ext>
+            </a:extLst>
+          </p:cNvPr>
+          <p:cNvSpPr txBox="1"/>
+          <p:nvPr/>
+        </p:nvSpPr>
+        <p:spPr>
+          <a:xfrm>
+            <a:off x="217714" y="255046"/>
+            <a:ext cx="11756571" cy="355354"/>
+          </a:xfrm>
+          <a:prstGeom prst="rect">
+            <a:avLst/>
+          </a:prstGeom>
+          <a:noFill/>
+        </p:spPr>
+        <p:txBody>
+          <a:bodyPr wrap="square">
+            <a:spAutoFit/>
+          </a:bodyPr>
+          <a:lstStyle/>
+          <a:p>
+            <a:pPr>
+              <a:lnSpc>
+                <a:spcPct val="150000"/>
+              </a:lnSpc>
+              <a:buNone/>
+            </a:pPr>
+            <a:r>
+              <a:rPr kumimoji="0" lang="en-US" altLang="en-US" sz="1300" b="0" i="0" u="none" strike="noStrike" cap="none" normalizeH="0" baseline="0">
+                <a:ln>
+                  <a:noFill/>
+                </a:ln>
+                <a:solidFill>
+                  <a:schemeClr val="tx1"/>
+                </a:solidFill>
+                <a:effectLst/>
+                <a:latin typeface="Arial" panose="020B0604020202020204" pitchFamily="34" charset="0"/>
+              </a:rPr>
+              <a:t>.</a:t>
+            </a:r>
+          </a:p>
+        </p:txBody>
+      </p:sp>
+    </p:spTree>
+    <p:extLst>
+      <p:ext uri="{BB962C8B-B14F-4D97-AF65-F5344CB8AC3E}">
+        <p14:creationId xmlns:p14="http://schemas.microsoft.com/office/powerpoint/2010/main" val="2379130137"/>
+      </p:ext>
+    </p:extLst>
+  </p:cSld>
+  <p:clrMapOvr>
+    <a:masterClrMapping/>
+  </p:clrMapOvr>
+</p:sld>
+</file>
+
+<file path=ppt/slides/slide7.xml><?xml version="1.0" encoding="utf-8"?>
+<p:sld xmlns:a="http://schemas.openxmlformats.org/drawingml/2006/main" xmlns:r="http://schemas.openxmlformats.org/officeDocument/2006/relationships" xmlns:p="http://schemas.openxmlformats.org/presentationml/2006/main">
+  <p:cSld>
+    <p:spTree>
+      <p:nvGrpSpPr>
+        <p:cNvPr id="1" name="">
+          <a:extLst>
+            <a:ext uri="{FF2B5EF4-FFF2-40B4-BE49-F238E27FC236}">
+              <a16:creationId xmlns:a16="http://schemas.microsoft.com/office/drawing/2014/main" id="{DDF0779F-D0F6-F5B5-D48B-0A5089CB1CAD}"/>
+            </a:ext>
+          </a:extLst>
+        </p:cNvPr>
+        <p:cNvGrpSpPr/>
+        <p:nvPr/>
+      </p:nvGrpSpPr>
+      <p:grpSpPr>
+        <a:xfrm>
+          <a:off x="0" y="0"/>
+          <a:ext cx="0" cy="0"/>
+          <a:chOff x="0" y="0"/>
+          <a:chExt cx="0" cy="0"/>
+        </a:xfrm>
+      </p:grpSpPr>
+      <p:sp>
+        <p:nvSpPr>
+          <p:cNvPr id="3" name="TextBox 2">
+            <a:extLst>
+              <a:ext uri="{FF2B5EF4-FFF2-40B4-BE49-F238E27FC236}">
+                <a16:creationId xmlns:a16="http://schemas.microsoft.com/office/drawing/2014/main" id="{E4FDFC7B-56D3-249C-A5DB-3496846B0004}"/>
+              </a:ext>
+            </a:extLst>
+          </p:cNvPr>
+          <p:cNvSpPr txBox="1"/>
+          <p:nvPr/>
+        </p:nvSpPr>
+        <p:spPr>
+          <a:xfrm>
+            <a:off x="217714" y="255046"/>
+            <a:ext cx="11756571" cy="355354"/>
+          </a:xfrm>
+          <a:prstGeom prst="rect">
+            <a:avLst/>
+          </a:prstGeom>
+          <a:noFill/>
+        </p:spPr>
+        <p:txBody>
+          <a:bodyPr wrap="square">
+            <a:spAutoFit/>
+          </a:bodyPr>
+          <a:lstStyle/>
+          <a:p>
+            <a:pPr>
+              <a:lnSpc>
+                <a:spcPct val="150000"/>
+              </a:lnSpc>
+              <a:buNone/>
+            </a:pPr>
+            <a:r>
+              <a:rPr kumimoji="0" lang="en-US" altLang="en-US" sz="1300" b="0" i="0" u="none" strike="noStrike" cap="none" normalizeH="0" baseline="0">
+                <a:ln>
+                  <a:noFill/>
+                </a:ln>
+                <a:solidFill>
+                  <a:schemeClr val="tx1"/>
+                </a:solidFill>
+                <a:effectLst/>
+                <a:latin typeface="Arial" panose="020B0604020202020204" pitchFamily="34" charset="0"/>
+              </a:rPr>
+              <a:t>.</a:t>
+            </a:r>
+          </a:p>
+        </p:txBody>
+      </p:sp>
+    </p:spTree>
+    <p:extLst>
+      <p:ext uri="{BB962C8B-B14F-4D97-AF65-F5344CB8AC3E}">
+        <p14:creationId xmlns:p14="http://schemas.microsoft.com/office/powerpoint/2010/main" val="2981942199"/>
       </p:ext>
     </p:extLst>
   </p:cSld>

</xml_diff>